<commit_message>
deck: team name ANYTHING AH into title-slide hero badge (drop standalone team line)
Co-authored-by: CommandCodeBot <noreply@commandcode.ai>
</commit_message>
<xml_diff>
--- a/docs/presentation/ShopCopilot_TechJam_Deck.pptx
+++ b/docs/presentation/ShopCopilot_TechJam_Deck.pptx
@@ -3675,7 +3675,7 @@
         <p:spPr>
           <a:xfrm>
             <a:off x="731520" y="1051560"/>
-            <a:ext cx="2926080" cy="347472"/>
+            <a:ext cx="4343400" cy="347472"/>
           </a:xfrm>
           <a:prstGeom prst="roundRect">
             <a:avLst>
@@ -3702,7 +3702,7 @@
         <p:spPr>
           <a:xfrm>
             <a:off x="822960" y="1097280"/>
-            <a:ext cx="2743200" cy="256032"/>
+            <a:ext cx="4160520" cy="256032"/>
           </a:xfrm>
           <a:prstGeom prst="rect">
             <a:avLst/>
@@ -3728,6 +3728,20 @@
               </a:rPr>
               <a:t>TIKTOK TECHJAM 2026 · TRACK 4</a:t>
             </a:r>
+            <a:pPr indent="0" marL="0">
+              <a:buNone/>
+            </a:pPr>
+            <a:r>
+              <a:rPr lang="en-US" sz="1000" b="1" dirty="0">
+                <a:solidFill>
+                  <a:srgbClr val="1B1F2E"/>
+                </a:solidFill>
+                <a:latin typeface="Segoe UI" pitchFamily="34" charset="0"/>
+                <a:ea typeface="Segoe UI" pitchFamily="34" charset="-122"/>
+                <a:cs typeface="Segoe UI" pitchFamily="34" charset="-120"/>
+              </a:rPr>
+              <a:t>   ·   ANYTHING AH</a:t>
+            </a:r>
             <a:endParaRPr lang="en-US" sz="1000" dirty="0"/>
           </a:p>
         </p:txBody>
@@ -3812,60 +3826,7 @@
       </p:sp>
       <p:sp>
         <p:nvSpPr>
-          <p:cNvPr id="6" name="Text 4"/>
-          <p:cNvSpPr/>
-          <p:nvPr/>
-        </p:nvSpPr>
-        <p:spPr>
-          <a:xfrm>
-            <a:off x="731520" y="2926080"/>
-            <a:ext cx="10515600" cy="320040"/>
-          </a:xfrm>
-          <a:prstGeom prst="rect">
-            <a:avLst/>
-          </a:prstGeom>
-          <a:noFill/>
-          <a:ln/>
-        </p:spPr>
-        <p:txBody>
-          <a:bodyPr wrap="square" rtlCol="0" anchor="ctr"/>
-          <a:lstStyle/>
-          <a:p>
-            <a:pPr indent="0" marL="0">
-              <a:buNone/>
-            </a:pPr>
-            <a:r>
-              <a:rPr lang="en-US" sz="1100" b="1" dirty="0">
-                <a:solidFill>
-                  <a:srgbClr val="8A7A5E"/>
-                </a:solidFill>
-                <a:latin typeface="Segoe UI" pitchFamily="34" charset="0"/>
-                <a:ea typeface="Segoe UI" pitchFamily="34" charset="-122"/>
-                <a:cs typeface="Segoe UI" pitchFamily="34" charset="-120"/>
-              </a:rPr>
-              <a:t>TEAM   </a:t>
-            </a:r>
-            <a:pPr indent="0" marL="0">
-              <a:buNone/>
-            </a:pPr>
-            <a:r>
-              <a:rPr lang="en-US" sz="1500" b="1" dirty="0">
-                <a:solidFill>
-                  <a:srgbClr val="1B1F2E"/>
-                </a:solidFill>
-                <a:latin typeface="Segoe UI" pitchFamily="34" charset="0"/>
-                <a:ea typeface="Segoe UI" pitchFamily="34" charset="-122"/>
-                <a:cs typeface="Segoe UI" pitchFamily="34" charset="-120"/>
-              </a:rPr>
-              <a:t>Anything Ah</a:t>
-            </a:r>
-            <a:endParaRPr lang="en-US" sz="1100" dirty="0"/>
-          </a:p>
-        </p:txBody>
-      </p:sp>
-      <p:sp>
-        <p:nvSpPr>
-          <p:cNvPr id="7" name="Shape 5"/>
+          <p:cNvPr id="6" name="Shape 4"/>
           <p:cNvSpPr/>
           <p:nvPr/>
         </p:nvSpPr>
@@ -3892,7 +3853,7 @@
       </p:sp>
       <p:sp>
         <p:nvSpPr>
-          <p:cNvPr id="8" name="Text 6"/>
+          <p:cNvPr id="7" name="Text 5"/>
           <p:cNvSpPr/>
           <p:nvPr/>
         </p:nvSpPr>
@@ -3931,7 +3892,7 @@
       </p:sp>
       <p:sp>
         <p:nvSpPr>
-          <p:cNvPr id="9" name="Text 7"/>
+          <p:cNvPr id="8" name="Text 6"/>
           <p:cNvSpPr/>
           <p:nvPr/>
         </p:nvSpPr>
@@ -3970,7 +3931,7 @@
       </p:sp>
       <p:sp>
         <p:nvSpPr>
-          <p:cNvPr id="10" name="Text 8"/>
+          <p:cNvPr id="9" name="Text 7"/>
           <p:cNvSpPr/>
           <p:nvPr/>
         </p:nvSpPr>
@@ -4009,7 +3970,7 @@
       </p:sp>
       <p:sp>
         <p:nvSpPr>
-          <p:cNvPr id="11" name="Shape 9"/>
+          <p:cNvPr id="10" name="Shape 8"/>
           <p:cNvSpPr/>
           <p:nvPr/>
         </p:nvSpPr>
@@ -4036,7 +3997,7 @@
       </p:sp>
       <p:sp>
         <p:nvSpPr>
-          <p:cNvPr id="12" name="Text 10"/>
+          <p:cNvPr id="11" name="Text 9"/>
           <p:cNvSpPr/>
           <p:nvPr/>
         </p:nvSpPr>
@@ -4075,7 +4036,7 @@
       </p:sp>
       <p:sp>
         <p:nvSpPr>
-          <p:cNvPr id="13" name="Text 11"/>
+          <p:cNvPr id="12" name="Text 10"/>
           <p:cNvSpPr/>
           <p:nvPr/>
         </p:nvSpPr>
@@ -4114,7 +4075,7 @@
       </p:sp>
       <p:sp>
         <p:nvSpPr>
-          <p:cNvPr id="14" name="Text 12"/>
+          <p:cNvPr id="13" name="Text 11"/>
           <p:cNvSpPr/>
           <p:nvPr/>
         </p:nvSpPr>
@@ -4153,7 +4114,7 @@
       </p:sp>
       <p:sp>
         <p:nvSpPr>
-          <p:cNvPr id="15" name="Shape 13"/>
+          <p:cNvPr id="14" name="Shape 12"/>
           <p:cNvSpPr/>
           <p:nvPr/>
         </p:nvSpPr>
@@ -4180,7 +4141,7 @@
       </p:sp>
       <p:sp>
         <p:nvSpPr>
-          <p:cNvPr id="16" name="Text 14"/>
+          <p:cNvPr id="15" name="Text 13"/>
           <p:cNvSpPr/>
           <p:nvPr/>
         </p:nvSpPr>
@@ -4219,7 +4180,7 @@
       </p:sp>
       <p:sp>
         <p:nvSpPr>
-          <p:cNvPr id="17" name="Text 15"/>
+          <p:cNvPr id="16" name="Text 14"/>
           <p:cNvSpPr/>
           <p:nvPr/>
         </p:nvSpPr>
@@ -4258,7 +4219,7 @@
       </p:sp>
       <p:sp>
         <p:nvSpPr>
-          <p:cNvPr id="18" name="Text 16"/>
+          <p:cNvPr id="17" name="Text 15"/>
           <p:cNvSpPr/>
           <p:nvPr/>
         </p:nvSpPr>
@@ -4297,7 +4258,7 @@
       </p:sp>
       <p:sp>
         <p:nvSpPr>
-          <p:cNvPr id="19" name="Shape 17"/>
+          <p:cNvPr id="18" name="Shape 16"/>
           <p:cNvSpPr/>
           <p:nvPr/>
         </p:nvSpPr>
@@ -4324,7 +4285,7 @@
       </p:sp>
       <p:sp>
         <p:nvSpPr>
-          <p:cNvPr id="20" name="Text 18"/>
+          <p:cNvPr id="19" name="Text 17"/>
           <p:cNvSpPr/>
           <p:nvPr/>
         </p:nvSpPr>
@@ -4363,7 +4324,7 @@
       </p:sp>
       <p:sp>
         <p:nvSpPr>
-          <p:cNvPr id="21" name="Text 19"/>
+          <p:cNvPr id="20" name="Text 18"/>
           <p:cNvSpPr/>
           <p:nvPr/>
         </p:nvSpPr>
@@ -4402,7 +4363,7 @@
       </p:sp>
       <p:sp>
         <p:nvSpPr>
-          <p:cNvPr id="22" name="Text 20"/>
+          <p:cNvPr id="21" name="Text 19"/>
           <p:cNvSpPr/>
           <p:nvPr/>
         </p:nvSpPr>
@@ -4441,7 +4402,7 @@
       </p:sp>
       <p:sp>
         <p:nvSpPr>
-          <p:cNvPr id="23" name="Text 21"/>
+          <p:cNvPr id="22" name="Text 20"/>
           <p:cNvSpPr/>
           <p:nvPr/>
         </p:nvSpPr>

</xml_diff>

<commit_message>
deck: drop GPT-4o-mini from LLM probe card/notes/script; latency range now +2.2-8.3 s (free-tier measurements only)
Co-authored-by: CommandCodeBot <noreply@commandcode.ai>
</commit_message>
<xml_diff>
--- a/docs/presentation/ShopCopilot_TechJam_Deck.pptx
+++ b/docs/presentation/ShopCopilot_TechJam_Deck.pptx
@@ -2847,7 +2847,7 @@
           <a:p>
             <a:r>
               <a:rPr lang="en-US" dirty="0"/>
-              <a:t>Say: We attempted every applicable direction on the organizer's own list. [POINT left] The left panel shipped. [POINT right] The right panel died. We probed three LLM classes — a 2.6B dense, a 30B-active-3B MoE, a 120B MoE, plus GPT-4o-mini: accuracy flat, latency half a second to eight seconds per call — and a local LLM on a consumer laptop loses on time-to-first-token alone. Our deterministic path stays at 330 milliseconds. [ADVANCE]
+              <a:t>Say: We attempted every applicable direction on the organizer's own list. [POINT left] The left panel shipped. [POINT right] The right panel died. We probed three LLM classes — a 2.6B dense, a 30B-active-3B MoE, a 120B MoE: accuracy flat, latency two to eight seconds per call — and a local LLM on a consumer laptop loses on time-to-first-token alone. Our deterministic path stays at 330 milliseconds. [ADVANCE]
 Timing: 30s</a:t>
             </a:r>
             <a:endParaRPr lang="en-US" dirty="0"/>
@@ -12413,7 +12413,7 @@
                 <a:ea typeface="Segoe UI" pitchFamily="34" charset="-122"/>
                 <a:cs typeface="Segoe UI" pitchFamily="34" charset="-120"/>
               </a:rPr>
-              <a:t>3 sizes &amp; classes probed — 2.6B dense · 30B-A3B · 120B-A12B MoE + GPT-4o-mini · Hit / MRR ≈ flat</a:t>
+              <a:t>3 sizes &amp; classes probed — 2.6B dense · 30B-A3B · 120B-A12B MoE · Hit / MRR ≈ flat</a:t>
             </a:r>
             <a:endParaRPr lang="en-US" sz="1150" dirty="0"/>
           </a:p>
@@ -12454,7 +12454,7 @@
                 <a:ea typeface="Consolas" pitchFamily="34" charset="-122"/>
                 <a:cs typeface="Consolas" pitchFamily="34" charset="-120"/>
               </a:rPr>
-              <a:t>ΔHit 0 · ΔMRR −0.005 · +0.5–8.3 s per call → killed · local LLM loses on TTFT too</a:t>
+              <a:t>ΔHit 0 · ΔMRR −0.005 · +2.2–8.3 s per call → killed · local LLM loses on TTFT too</a:t>
             </a:r>
             <a:endParaRPr lang="en-US" sz="1150" dirty="0"/>
           </a:p>

</xml_diff>

<commit_message>
deck: add group ANYTHING AH to all slide headers/footers + pptx author/company metadata
Co-authored-by: CommandCodeBot <noreply@commandcode.ai>
</commit_message>
<xml_diff>
--- a/docs/presentation/ShopCopilot_TechJam_Deck.pptx
+++ b/docs/presentation/ShopCopilot_TechJam_Deck.pptx
@@ -4433,7 +4433,7 @@
                 <a:ea typeface="Consolas" pitchFamily="34" charset="-122"/>
                 <a:cs typeface="Consolas" pitchFamily="34" charset="-120"/>
               </a:rPr>
-              <a:t>ShopCopilot · TechJam 2026 · submission-freeze 46e3322  |  Data: Amazon Reviews 2023, McAuley Lab, UCSD</a:t>
+              <a:t>ShopCopilot · TechJam 2026 · Anything Ah · submission-freeze 46e3322  |  Data: Amazon Reviews 2023, McAuley Lab, UCSD</a:t>
             </a:r>
             <a:endParaRPr lang="en-US" sz="900" dirty="0"/>
           </a:p>
@@ -4504,7 +4504,7 @@
                 <a:ea typeface="Segoe UI" pitchFamily="34" charset="-122"/>
                 <a:cs typeface="Segoe UI" pitchFamily="34" charset="-120"/>
               </a:rPr>
-              <a:t>SHOPCOPILOT · TECHJAM 2026</a:t>
+              <a:t>SHOPCOPILOT · TECHJAM 2026 · ANYTHING AH</a:t>
             </a:r>
             <a:endParaRPr lang="en-US" sz="1000" dirty="0"/>
           </a:p>
@@ -5283,7 +5283,7 @@
                 <a:ea typeface="Consolas" pitchFamily="34" charset="-122"/>
                 <a:cs typeface="Consolas" pitchFamily="34" charset="-120"/>
               </a:rPr>
-              <a:t>ShopCopilot · TechJam 2026 · submission-freeze 46e3322</a:t>
+              <a:t>ShopCopilot · TechJam 2026 · Anything Ah · submission-freeze 46e3322</a:t>
             </a:r>
             <a:endParaRPr lang="en-US" sz="900" dirty="0"/>
           </a:p>
@@ -5354,7 +5354,7 @@
                 <a:ea typeface="Segoe UI" pitchFamily="34" charset="-122"/>
                 <a:cs typeface="Segoe UI" pitchFamily="34" charset="-120"/>
               </a:rPr>
-              <a:t>SHOPCOPILOT · TECHJAM 2026</a:t>
+              <a:t>SHOPCOPILOT · TECHJAM 2026 · ANYTHING AH</a:t>
             </a:r>
             <a:endParaRPr lang="en-US" sz="1000" dirty="0"/>
           </a:p>
@@ -6482,7 +6482,7 @@
                 <a:ea typeface="Consolas" pitchFamily="34" charset="-122"/>
                 <a:cs typeface="Consolas" pitchFamily="34" charset="-120"/>
               </a:rPr>
-              <a:t>ShopCopilot · TechJam 2026 · submission-freeze 46e3322</a:t>
+              <a:t>ShopCopilot · TechJam 2026 · Anything Ah · submission-freeze 46e3322</a:t>
             </a:r>
             <a:endParaRPr lang="en-US" sz="900" dirty="0"/>
           </a:p>
@@ -6553,7 +6553,7 @@
                 <a:ea typeface="Segoe UI" pitchFamily="34" charset="-122"/>
                 <a:cs typeface="Segoe UI" pitchFamily="34" charset="-120"/>
               </a:rPr>
-              <a:t>SHOPCOPILOT · TECHJAM 2026</a:t>
+              <a:t>SHOPCOPILOT · TECHJAM 2026 · ANYTHING AH</a:t>
             </a:r>
             <a:endParaRPr lang="en-US" sz="1000" dirty="0"/>
           </a:p>
@@ -7142,7 +7142,7 @@
                 <a:ea typeface="Consolas" pitchFamily="34" charset="-122"/>
                 <a:cs typeface="Consolas" pitchFamily="34" charset="-120"/>
               </a:rPr>
-              <a:t>ShopCopilot · TechJam 2026 · submission-freeze 46e3322</a:t>
+              <a:t>ShopCopilot · TechJam 2026 · Anything Ah · submission-freeze 46e3322</a:t>
             </a:r>
             <a:endParaRPr lang="en-US" sz="900" dirty="0"/>
           </a:p>
@@ -7213,7 +7213,7 @@
                 <a:ea typeface="Segoe UI" pitchFamily="34" charset="-122"/>
                 <a:cs typeface="Segoe UI" pitchFamily="34" charset="-120"/>
               </a:rPr>
-              <a:t>SHOPCOPILOT · TECHJAM 2026</a:t>
+              <a:t>SHOPCOPILOT · TECHJAM 2026 · ANYTHING AH</a:t>
             </a:r>
             <a:endParaRPr lang="en-US" sz="1000" dirty="0"/>
           </a:p>
@@ -8185,7 +8185,7 @@
                 <a:ea typeface="Consolas" pitchFamily="34" charset="-122"/>
                 <a:cs typeface="Consolas" pitchFamily="34" charset="-120"/>
               </a:rPr>
-              <a:t>ShopCopilot · TechJam 2026 · submission-freeze 46e3322</a:t>
+              <a:t>ShopCopilot · TechJam 2026 · Anything Ah · submission-freeze 46e3322</a:t>
             </a:r>
             <a:endParaRPr lang="en-US" sz="900" dirty="0"/>
           </a:p>
@@ -8256,7 +8256,7 @@
                 <a:ea typeface="Segoe UI" pitchFamily="34" charset="-122"/>
                 <a:cs typeface="Segoe UI" pitchFamily="34" charset="-120"/>
               </a:rPr>
-              <a:t>SHOPCOPILOT · TECHJAM 2026</a:t>
+              <a:t>SHOPCOPILOT · TECHJAM 2026 · ANYTHING AH</a:t>
             </a:r>
             <a:endParaRPr lang="en-US" sz="1000" dirty="0"/>
           </a:p>
@@ -8985,7 +8985,7 @@
                 <a:ea typeface="Consolas" pitchFamily="34" charset="-122"/>
                 <a:cs typeface="Consolas" pitchFamily="34" charset="-120"/>
               </a:rPr>
-              <a:t>ShopCopilot · TechJam 2026 · submission-freeze 46e3322</a:t>
+              <a:t>ShopCopilot · TechJam 2026 · Anything Ah · submission-freeze 46e3322</a:t>
             </a:r>
             <a:endParaRPr lang="en-US" sz="900" dirty="0"/>
           </a:p>
@@ -9056,7 +9056,7 @@
                 <a:ea typeface="Segoe UI" pitchFamily="34" charset="-122"/>
                 <a:cs typeface="Segoe UI" pitchFamily="34" charset="-120"/>
               </a:rPr>
-              <a:t>SHOPCOPILOT · TECHJAM 2026</a:t>
+              <a:t>SHOPCOPILOT · TECHJAM 2026 · ANYTHING AH</a:t>
             </a:r>
             <a:endParaRPr lang="en-US" sz="1000" dirty="0"/>
           </a:p>
@@ -9718,7 +9718,7 @@
                 <a:ea typeface="Consolas" pitchFamily="34" charset="-122"/>
                 <a:cs typeface="Consolas" pitchFamily="34" charset="-120"/>
               </a:rPr>
-              <a:t>ShopCopilot · TechJam 2026 · submission-freeze 46e3322  |  Data Attribution: Amazon Reviews 2023, McAuley Lab, UCSD</a:t>
+              <a:t>ShopCopilot · TechJam 2026 · Anything Ah · submission-freeze 46e3322  |  Data Attribution: Amazon Reviews 2023, McAuley Lab, UCSD</a:t>
             </a:r>
             <a:endParaRPr lang="en-US" sz="900" dirty="0"/>
           </a:p>
@@ -9789,7 +9789,7 @@
                 <a:ea typeface="Segoe UI" pitchFamily="34" charset="-122"/>
                 <a:cs typeface="Segoe UI" pitchFamily="34" charset="-120"/>
               </a:rPr>
-              <a:t>SHOPCOPILOT · TECHJAM 2026</a:t>
+              <a:t>SHOPCOPILOT · TECHJAM 2026 · ANYTHING AH</a:t>
             </a:r>
             <a:endParaRPr lang="en-US" sz="1000" dirty="0"/>
           </a:p>
@@ -11129,7 +11129,7 @@
                 <a:ea typeface="Consolas" pitchFamily="34" charset="-122"/>
                 <a:cs typeface="Consolas" pitchFamily="34" charset="-120"/>
               </a:rPr>
-              <a:t>ShopCopilot · TechJam 2026 · submission-freeze 46e3322</a:t>
+              <a:t>ShopCopilot · TechJam 2026 · Anything Ah · submission-freeze 46e3322</a:t>
             </a:r>
             <a:endParaRPr lang="en-US" sz="900" dirty="0"/>
           </a:p>
@@ -11200,7 +11200,7 @@
                 <a:ea typeface="Segoe UI" pitchFamily="34" charset="-122"/>
                 <a:cs typeface="Segoe UI" pitchFamily="34" charset="-120"/>
               </a:rPr>
-              <a:t>SHOPCOPILOT · TECHJAM 2026</a:t>
+              <a:t>SHOPCOPILOT · TECHJAM 2026 · ANYTHING AH</a:t>
             </a:r>
             <a:endParaRPr lang="en-US" sz="1000" dirty="0"/>
           </a:p>
@@ -11684,7 +11684,7 @@
                 <a:ea typeface="Consolas" pitchFamily="34" charset="-122"/>
                 <a:cs typeface="Consolas" pitchFamily="34" charset="-120"/>
               </a:rPr>
-              <a:t>ShopCopilot · TechJam 2026 · submission-freeze 46e3322</a:t>
+              <a:t>ShopCopilot · TechJam 2026 · Anything Ah · submission-freeze 46e3322</a:t>
             </a:r>
             <a:endParaRPr lang="en-US" sz="900" dirty="0"/>
           </a:p>
@@ -11755,7 +11755,7 @@
                 <a:ea typeface="Segoe UI" pitchFamily="34" charset="-122"/>
                 <a:cs typeface="Segoe UI" pitchFamily="34" charset="-120"/>
               </a:rPr>
-              <a:t>SHOPCOPILOT · TECHJAM 2026</a:t>
+              <a:t>SHOPCOPILOT · TECHJAM 2026 · ANYTHING AH</a:t>
             </a:r>
             <a:endParaRPr lang="en-US" sz="1000" dirty="0"/>
           </a:p>
@@ -12735,7 +12735,7 @@
                 <a:ea typeface="Consolas" pitchFamily="34" charset="-122"/>
                 <a:cs typeface="Consolas" pitchFamily="34" charset="-120"/>
               </a:rPr>
-              <a:t>ShopCopilot · TechJam 2026 · submission-freeze 46e3322</a:t>
+              <a:t>ShopCopilot · TechJam 2026 · Anything Ah · submission-freeze 46e3322</a:t>
             </a:r>
             <a:endParaRPr lang="en-US" sz="900" dirty="0"/>
           </a:p>
@@ -12806,7 +12806,7 @@
                 <a:ea typeface="Segoe UI" pitchFamily="34" charset="-122"/>
                 <a:cs typeface="Segoe UI" pitchFamily="34" charset="-120"/>
               </a:rPr>
-              <a:t>SHOPCOPILOT · TECHJAM 2026</a:t>
+              <a:t>SHOPCOPILOT · TECHJAM 2026 · ANYTHING AH</a:t>
             </a:r>
             <a:endParaRPr lang="en-US" sz="1000" dirty="0"/>
           </a:p>
@@ -13505,7 +13505,7 @@
                 <a:ea typeface="Consolas" pitchFamily="34" charset="-122"/>
                 <a:cs typeface="Consolas" pitchFamily="34" charset="-120"/>
               </a:rPr>
-              <a:t>ShopCopilot · TechJam 2026 · submission-freeze 46e3322</a:t>
+              <a:t>ShopCopilot · TechJam 2026 · Anything Ah · submission-freeze 46e3322</a:t>
             </a:r>
             <a:endParaRPr lang="en-US" sz="900" dirty="0"/>
           </a:p>
@@ -13576,7 +13576,7 @@
                 <a:ea typeface="Segoe UI" pitchFamily="34" charset="-122"/>
                 <a:cs typeface="Segoe UI" pitchFamily="34" charset="-120"/>
               </a:rPr>
-              <a:t>SHOPCOPILOT · TECHJAM 2026</a:t>
+              <a:t>SHOPCOPILOT · TECHJAM 2026 · ANYTHING AH</a:t>
             </a:r>
             <a:endParaRPr lang="en-US" sz="1000" dirty="0"/>
           </a:p>
@@ -14582,7 +14582,7 @@
                 <a:ea typeface="Consolas" pitchFamily="34" charset="-122"/>
                 <a:cs typeface="Consolas" pitchFamily="34" charset="-120"/>
               </a:rPr>
-              <a:t>ShopCopilot · TechJam 2026 · submission-freeze 46e3322</a:t>
+              <a:t>ShopCopilot · TechJam 2026 · Anything Ah · submission-freeze 46e3322</a:t>
             </a:r>
             <a:endParaRPr lang="en-US" sz="900" dirty="0"/>
           </a:p>
@@ -14653,7 +14653,7 @@
                 <a:ea typeface="Segoe UI" pitchFamily="34" charset="-122"/>
                 <a:cs typeface="Segoe UI" pitchFamily="34" charset="-120"/>
               </a:rPr>
-              <a:t>SHOPCOPILOT · TECHJAM 2026</a:t>
+              <a:t>SHOPCOPILOT · TECHJAM 2026 · ANYTHING AH</a:t>
             </a:r>
             <a:endParaRPr lang="en-US" sz="1000" dirty="0"/>
           </a:p>
@@ -15273,7 +15273,7 @@
                 <a:ea typeface="Consolas" pitchFamily="34" charset="-122"/>
                 <a:cs typeface="Consolas" pitchFamily="34" charset="-120"/>
               </a:rPr>
-              <a:t>ShopCopilot · TechJam 2026 · submission-freeze 46e3322</a:t>
+              <a:t>ShopCopilot · TechJam 2026 · Anything Ah · submission-freeze 46e3322</a:t>
             </a:r>
             <a:endParaRPr lang="en-US" sz="900" dirty="0"/>
           </a:p>
@@ -15344,7 +15344,7 @@
                 <a:ea typeface="Segoe UI" pitchFamily="34" charset="-122"/>
                 <a:cs typeface="Segoe UI" pitchFamily="34" charset="-120"/>
               </a:rPr>
-              <a:t>SHOPCOPILOT · TECHJAM 2026</a:t>
+              <a:t>SHOPCOPILOT · TECHJAM 2026 · ANYTHING AH</a:t>
             </a:r>
             <a:endParaRPr lang="en-US" sz="1000" dirty="0"/>
           </a:p>
@@ -17038,7 +17038,7 @@
                 <a:ea typeface="Consolas" pitchFamily="34" charset="-122"/>
                 <a:cs typeface="Consolas" pitchFamily="34" charset="-120"/>
               </a:rPr>
-              <a:t>ShopCopilot · TechJam 2026 · submission-freeze 46e3322</a:t>
+              <a:t>ShopCopilot · TechJam 2026 · Anything Ah · submission-freeze 46e3322</a:t>
             </a:r>
             <a:endParaRPr lang="en-US" sz="900" dirty="0"/>
           </a:p>
@@ -17109,7 +17109,7 @@
                 <a:ea typeface="Segoe UI" pitchFamily="34" charset="-122"/>
                 <a:cs typeface="Segoe UI" pitchFamily="34" charset="-120"/>
               </a:rPr>
-              <a:t>SHOPCOPILOT · TECHJAM 2026</a:t>
+              <a:t>SHOPCOPILOT · TECHJAM 2026 · ANYTHING AH</a:t>
             </a:r>
             <a:endParaRPr lang="en-US" sz="1000" dirty="0"/>
           </a:p>
@@ -18063,7 +18063,7 @@
                 <a:ea typeface="Consolas" pitchFamily="34" charset="-122"/>
                 <a:cs typeface="Consolas" pitchFamily="34" charset="-120"/>
               </a:rPr>
-              <a:t>ShopCopilot · TechJam 2026 · submission-freeze 46e3322</a:t>
+              <a:t>ShopCopilot · TechJam 2026 · Anything Ah · submission-freeze 46e3322</a:t>
             </a:r>
             <a:endParaRPr lang="en-US" sz="900" dirty="0"/>
           </a:p>

</xml_diff>